<commit_message>
generate reference hygiene report integration tests
</commit_message>
<xml_diff>
--- a/tests/report_generator/integration/references/reference_hygiene-report.pptx
+++ b/tests/report_generator/integration/references/reference_hygiene-report.pptx
@@ -759,10 +759,10 @@
                   <c:v>12</c:v>
                 </c:pt>
                 <c:pt idx="1">
+                  <c:v>12</c:v>
+                </c:pt>
+                <c:pt idx="2">
                   <c:v>0</c:v>
-                </c:pt>
-                <c:pt idx="2">
-                  <c:v>12</c:v>
                 </c:pt>
                 <c:pt idx="3">
                   <c:v>0</c:v>
@@ -1719,10 +1719,10 @@
                   <c:v>1</c:v>
                 </c:pt>
                 <c:pt idx="1">
+                  <c:v>1</c:v>
+                </c:pt>
+                <c:pt idx="2">
                   <c:v>0</c:v>
-                </c:pt>
-                <c:pt idx="2">
-                  <c:v>1</c:v>
                 </c:pt>
                 <c:pt idx="3">
                   <c:v>0</c:v>

</xml_diff>

<commit_message>
implement feedback and regenerate integration test reference
</commit_message>
<xml_diff>
--- a/tests/report_generator/integration/references/reference_hygiene-report.pptx
+++ b/tests/report_generator/integration/references/reference_hygiene-report.pptx
@@ -313,34 +313,34 @@
                 <c:formatCode>General</c:formatCode>
                 <c:ptCount val="10"/>
                 <c:pt idx="0">
-                  <c:v>0.0</c:v>
+                  <c:v>0</c:v>
                 </c:pt>
                 <c:pt idx="1">
-                  <c:v>0.0</c:v>
+                  <c:v>0</c:v>
                 </c:pt>
                 <c:pt idx="2">
-                  <c:v>0.0</c:v>
+                  <c:v>0</c:v>
                 </c:pt>
                 <c:pt idx="3">
-                  <c:v>0.0</c:v>
+                  <c:v>0</c:v>
                 </c:pt>
                 <c:pt idx="4">
-                  <c:v>0.0</c:v>
+                  <c:v>0</c:v>
                 </c:pt>
                 <c:pt idx="5">
-                  <c:v>0.0</c:v>
+                  <c:v>0</c:v>
                 </c:pt>
                 <c:pt idx="6">
-                  <c:v>0.0</c:v>
+                  <c:v>0</c:v>
                 </c:pt>
                 <c:pt idx="7">
-                  <c:v>0.0</c:v>
+                  <c:v>0</c:v>
                 </c:pt>
                 <c:pt idx="8">
-                  <c:v>0.0</c:v>
+                  <c:v>0</c:v>
                 </c:pt>
                 <c:pt idx="9">
-                  <c:v>0.0</c:v>
+                  <c:v>0</c:v>
                 </c:pt>
               </c:numCache>
             </c:numRef>
@@ -423,34 +423,34 @@
                 <c:formatCode>General</c:formatCode>
                 <c:ptCount val="10"/>
                 <c:pt idx="0">
-                  <c:v>100.0</c:v>
+                  <c:v>100</c:v>
                 </c:pt>
                 <c:pt idx="1">
-                  <c:v>100.0</c:v>
+                  <c:v>100</c:v>
                 </c:pt>
                 <c:pt idx="2">
-                  <c:v>100.0</c:v>
+                  <c:v>100</c:v>
                 </c:pt>
                 <c:pt idx="3">
-                  <c:v>100.0</c:v>
+                  <c:v>100</c:v>
                 </c:pt>
                 <c:pt idx="4">
-                  <c:v>100.0</c:v>
+                  <c:v>100</c:v>
                 </c:pt>
                 <c:pt idx="5">
-                  <c:v>100.0</c:v>
+                  <c:v>100</c:v>
                 </c:pt>
                 <c:pt idx="6">
-                  <c:v>100.0</c:v>
+                  <c:v>100</c:v>
                 </c:pt>
                 <c:pt idx="7">
-                  <c:v>100.0</c:v>
+                  <c:v>100</c:v>
                 </c:pt>
                 <c:pt idx="8">
-                  <c:v>100.0</c:v>
+                  <c:v>100</c:v>
                 </c:pt>
                 <c:pt idx="9">
-                  <c:v>100.0</c:v>
+                  <c:v>100</c:v>
                 </c:pt>
               </c:numCache>
             </c:numRef>
@@ -1436,10 +1436,10 @@
                 <c:formatCode>General</c:formatCode>
                 <c:ptCount val="6"/>
                 <c:pt idx="0">
-                  <c:v>0</c:v>
+                  <c:v>1</c:v>
                 </c:pt>
                 <c:pt idx="1">
-                  <c:v>0</c:v>
+                  <c:v>1</c:v>
                 </c:pt>
                 <c:pt idx="2">
                   <c:v>0</c:v>
@@ -1716,10 +1716,10 @@
                 <c:formatCode>General</c:formatCode>
                 <c:ptCount val="6"/>
                 <c:pt idx="0">
-                  <c:v>1</c:v>
+                  <c:v>0</c:v>
                 </c:pt>
                 <c:pt idx="1">
-                  <c:v>1</c:v>
+                  <c:v>0</c:v>
                 </c:pt>
                 <c:pt idx="2">
                   <c:v>0</c:v>

</xml_diff>

<commit_message>
Update hygiene report reference
</commit_message>
<xml_diff>
--- a/tests/report_generator/integration/references/reference_hygiene-report.pptx
+++ b/tests/report_generator/integration/references/reference_hygiene-report.pptx
@@ -1437,10 +1437,10 @@
                 <c:formatCode>General</c:formatCode>
                 <c:ptCount val="6"/>
                 <c:pt idx="0">
-                  <c:v>1</c:v>
+                  <c:v>2</c:v>
                 </c:pt>
                 <c:pt idx="1">
-                  <c:v>1</c:v>
+                  <c:v>2</c:v>
                 </c:pt>
                 <c:pt idx="2">
                   <c:v>0</c:v>

</xml_diff>